<commit_message>
Rebrand to Sairaj S Kashid - single author project
</commit_message>
<xml_diff>
--- a/docs/CivicEye_AI_PPT.pptx
+++ b/docs/CivicEye_AI_PPT.pptx
@@ -3335,7 +3335,7 @@
               </a:defRPr>
             </a:pPr>
             <a:r>
-              <a:t>B.Tech CSE Capstone Project — Level 2  •  Group P52  •  MIT World Peace University, Pune</a:t>
+              <a:t>B.Tech CSE Capstone Project — Level 2  •  Sairaj S Kashid  •  MIT World Peace University, Pune</a:t>
             </a:r>
           </a:p>
         </p:txBody>
@@ -3457,7 +3457,7 @@
               </a:defRPr>
             </a:pPr>
             <a:r>
-              <a:t>GUIDE</a:t>
+              <a:t>AUTHOR</a:t>
             </a:r>
           </a:p>
         </p:txBody>
@@ -3493,7 +3493,7 @@
               </a:defRPr>
             </a:pPr>
             <a:r>
-              <a:t>Dr. Vitthal Sadashiv Gutte</a:t>
+              <a:t>Sairaj S Kashid</a:t>
             </a:r>
           </a:p>
         </p:txBody>
@@ -3529,7 +3529,7 @@
               </a:defRPr>
             </a:pPr>
             <a:r>
-              <a:t>TEAM P52</a:t>
+              <a:t>AUTHOR</a:t>
             </a:r>
           </a:p>
         </p:txBody>
@@ -3565,122 +3565,14 @@
               </a:defRPr>
             </a:pPr>
             <a:r>
-              <a:t>•  Mazin Ansari — 1032233483</a:t>
-            </a:r>
-          </a:p>
-        </p:txBody>
-      </p:sp>
-      <p:sp>
-        <p:nvSpPr>
-          <p:cNvPr id="14" name="TextBox 13"/>
-          <p:cNvSpPr txBox="1"/>
-          <p:nvPr/>
-        </p:nvSpPr>
-        <p:spPr>
-          <a:xfrm>
-            <a:off x="7863840" y="2926080"/>
-            <a:ext cx="3291840" cy="274320"/>
-          </a:xfrm>
-          <a:prstGeom prst="rect">
-            <a:avLst/>
-          </a:prstGeom>
-          <a:noFill/>
-        </p:spPr>
-        <p:txBody>
-          <a:bodyPr wrap="square">
-            <a:spAutoFit/>
-          </a:bodyPr>
-          <a:lstStyle/>
-          <a:p>
-            <a:pPr algn="l">
-              <a:defRPr sz="900" b="0">
-                <a:solidFill>
-                  <a:srgbClr val="0F172A"/>
-                </a:solidFill>
-                <a:latin typeface="Calibri"/>
-              </a:defRPr>
-            </a:pPr>
-            <a:r>
-              <a:t>•  Pawan Kumar Singh — 1032233471</a:t>
-            </a:r>
-          </a:p>
-        </p:txBody>
-      </p:sp>
-      <p:sp>
-        <p:nvSpPr>
-          <p:cNvPr id="15" name="TextBox 14"/>
-          <p:cNvSpPr txBox="1"/>
-          <p:nvPr/>
-        </p:nvSpPr>
-        <p:spPr>
-          <a:xfrm>
-            <a:off x="7863840" y="3246120"/>
-            <a:ext cx="3291840" cy="274320"/>
-          </a:xfrm>
-          <a:prstGeom prst="rect">
-            <a:avLst/>
-          </a:prstGeom>
-          <a:noFill/>
-        </p:spPr>
-        <p:txBody>
-          <a:bodyPr wrap="square">
-            <a:spAutoFit/>
-          </a:bodyPr>
-          <a:lstStyle/>
-          <a:p>
-            <a:pPr algn="l">
-              <a:defRPr sz="900" b="0">
-                <a:solidFill>
-                  <a:srgbClr val="0F172A"/>
-                </a:solidFill>
-                <a:latin typeface="Calibri"/>
-              </a:defRPr>
-            </a:pPr>
-            <a:r>
-              <a:t>•  Ayush Mahajan — 1032233492</a:t>
-            </a:r>
-          </a:p>
-        </p:txBody>
-      </p:sp>
-      <p:sp>
-        <p:nvSpPr>
-          <p:cNvPr id="16" name="TextBox 15"/>
-          <p:cNvSpPr txBox="1"/>
-          <p:nvPr/>
-        </p:nvSpPr>
-        <p:spPr>
-          <a:xfrm>
-            <a:off x="7863840" y="3566160"/>
-            <a:ext cx="3291840" cy="274320"/>
-          </a:xfrm>
-          <a:prstGeom prst="rect">
-            <a:avLst/>
-          </a:prstGeom>
-          <a:noFill/>
-        </p:spPr>
-        <p:txBody>
-          <a:bodyPr wrap="square">
-            <a:spAutoFit/>
-          </a:bodyPr>
-          <a:lstStyle/>
-          <a:p>
-            <a:pPr algn="l">
-              <a:defRPr sz="900" b="0">
-                <a:solidFill>
-                  <a:srgbClr val="0F172A"/>
-                </a:solidFill>
-                <a:latin typeface="Calibri"/>
-              </a:defRPr>
-            </a:pPr>
-            <a:r>
-              <a:t>•  Chaitanya Purkar — 1032233488</a:t>
-            </a:r>
-          </a:p>
-        </p:txBody>
-      </p:sp>
-      <p:sp>
-        <p:nvSpPr>
-          <p:cNvPr id="17" name="Rounded Rectangle 16"/>
+              <a:t>•  Sairaj S Kashid</a:t>
+            </a:r>
+          </a:p>
+        </p:txBody>
+      </p:sp>
+      <p:sp>
+        <p:nvSpPr>
+          <p:cNvPr id="14" name="Rounded Rectangle 13"/>
           <p:cNvSpPr/>
           <p:nvPr/>
         </p:nvSpPr>
@@ -3723,7 +3615,7 @@
       </p:sp>
       <p:sp>
         <p:nvSpPr>
-          <p:cNvPr id="18" name="TextBox 17"/>
+          <p:cNvPr id="15" name="TextBox 14"/>
           <p:cNvSpPr txBox="1"/>
           <p:nvPr/>
         </p:nvSpPr>
@@ -3759,7 +3651,7 @@
       </p:sp>
       <p:sp>
         <p:nvSpPr>
-          <p:cNvPr id="19" name="TextBox 18"/>
+          <p:cNvPr id="16" name="TextBox 15"/>
           <p:cNvSpPr txBox="1"/>
           <p:nvPr/>
         </p:nvSpPr>
@@ -3795,7 +3687,7 @@
       </p:sp>
       <p:sp>
         <p:nvSpPr>
-          <p:cNvPr id="20" name="Rounded Rectangle 19"/>
+          <p:cNvPr id="17" name="Rounded Rectangle 16"/>
           <p:cNvSpPr/>
           <p:nvPr/>
         </p:nvSpPr>
@@ -3838,7 +3730,7 @@
       </p:sp>
       <p:sp>
         <p:nvSpPr>
-          <p:cNvPr id="21" name="TextBox 20"/>
+          <p:cNvPr id="18" name="TextBox 17"/>
           <p:cNvSpPr txBox="1"/>
           <p:nvPr/>
         </p:nvSpPr>
@@ -3874,7 +3766,7 @@
       </p:sp>
       <p:sp>
         <p:nvSpPr>
-          <p:cNvPr id="22" name="TextBox 21"/>
+          <p:cNvPr id="19" name="TextBox 18"/>
           <p:cNvSpPr txBox="1"/>
           <p:nvPr/>
         </p:nvSpPr>
@@ -3910,7 +3802,7 @@
       </p:sp>
       <p:sp>
         <p:nvSpPr>
-          <p:cNvPr id="23" name="Rounded Rectangle 22"/>
+          <p:cNvPr id="20" name="Rounded Rectangle 19"/>
           <p:cNvSpPr/>
           <p:nvPr/>
         </p:nvSpPr>
@@ -3953,7 +3845,7 @@
       </p:sp>
       <p:sp>
         <p:nvSpPr>
-          <p:cNvPr id="24" name="TextBox 23"/>
+          <p:cNvPr id="21" name="TextBox 20"/>
           <p:cNvSpPr txBox="1"/>
           <p:nvPr/>
         </p:nvSpPr>
@@ -3989,7 +3881,7 @@
       </p:sp>
       <p:sp>
         <p:nvSpPr>
-          <p:cNvPr id="25" name="TextBox 24"/>
+          <p:cNvPr id="22" name="TextBox 21"/>
           <p:cNvSpPr txBox="1"/>
           <p:nvPr/>
         </p:nvSpPr>
@@ -4025,7 +3917,7 @@
       </p:sp>
       <p:sp>
         <p:nvSpPr>
-          <p:cNvPr id="26" name="Rounded Rectangle 25"/>
+          <p:cNvPr id="23" name="Rounded Rectangle 22"/>
           <p:cNvSpPr/>
           <p:nvPr/>
         </p:nvSpPr>
@@ -4068,7 +3960,7 @@
       </p:sp>
       <p:sp>
         <p:nvSpPr>
-          <p:cNvPr id="27" name="TextBox 26"/>
+          <p:cNvPr id="24" name="TextBox 23"/>
           <p:cNvSpPr txBox="1"/>
           <p:nvPr/>
         </p:nvSpPr>
@@ -4104,7 +3996,7 @@
       </p:sp>
       <p:sp>
         <p:nvSpPr>
-          <p:cNvPr id="28" name="TextBox 27"/>
+          <p:cNvPr id="25" name="TextBox 24"/>
           <p:cNvSpPr txBox="1"/>
           <p:nvPr/>
         </p:nvSpPr>
@@ -4140,7 +4032,7 @@
       </p:sp>
       <p:sp>
         <p:nvSpPr>
-          <p:cNvPr id="29" name="TextBox 28"/>
+          <p:cNvPr id="26" name="TextBox 25"/>
           <p:cNvSpPr txBox="1"/>
           <p:nvPr/>
         </p:nvSpPr>
@@ -4176,7 +4068,7 @@
       </p:sp>
       <p:sp>
         <p:nvSpPr>
-          <p:cNvPr id="30" name="TextBox 29"/>
+          <p:cNvPr id="27" name="TextBox 26"/>
           <p:cNvSpPr txBox="1"/>
           <p:nvPr/>
         </p:nvSpPr>
@@ -4205,7 +4097,7 @@
               </a:defRPr>
             </a:pPr>
             <a:r>
-              <a:t>Inhouse Project • Domain: AI / Computer Vision / Full-Stack / Smart City &amp; Civic-Tech</a:t>
+              <a:t>Individual Project • Sairaj S Kashid • Smart City &amp; Civic-Tech</a:t>
             </a:r>
           </a:p>
         </p:txBody>
@@ -13501,7 +13393,7 @@
               </a:defRPr>
             </a:pPr>
             <a:r>
-              <a:t>Group P52  •  MIT World Peace University, Pune</a:t>
+              <a:t>Sairaj S Kashid  •  MIT World Peace University, Pune</a:t>
             </a:r>
           </a:p>
         </p:txBody>
@@ -13537,15 +13429,15 @@
               </a:defRPr>
             </a:pPr>
             <a:r>
-              <a:t>Mazin Ansari • Pawan Kumar Singh • Ayush Mahajan • Chaitanya Purkar</a:t>
+              <a:t>Sairaj S Kashid</a:t>
             </a:r>
             <a:br/>
             <a:r>
-              <a:t>Guide: Dr. Vitthal Sadashiv Gutte</a:t>
+              <a:t>B.Tech CSE, MIT World Peace University, Pune</a:t>
             </a:r>
             <a:br/>
             <a:r>
-              <a:t>civiceye.p52@mitwpu.edu.in</a:t>
+              <a:t>sairajkashid-prog@github.com</a:t>
             </a:r>
           </a:p>
         </p:txBody>
@@ -17296,7 +17188,7 @@
               </a:defRPr>
             </a:pPr>
             <a:r>
-              <a:t>Mazin Ansari</a:t>
+              <a:t>Sairaj S Kashid</a:t>
             </a:r>
           </a:p>
         </p:txBody>
@@ -17332,7 +17224,7 @@
               </a:defRPr>
             </a:pPr>
             <a:r>
-              <a:t>Citizen App &amp; Auth</a:t>
+              <a:t>Full-Stack &amp; AI Development</a:t>
             </a:r>
           </a:p>
         </p:txBody>
@@ -17368,466 +17260,7 @@
               </a:defRPr>
             </a:pPr>
             <a:r>
-              <a:t>React auth, JWT, image/GPS capture, tracking UI, notification integration</a:t>
-            </a:r>
-          </a:p>
-        </p:txBody>
-      </p:sp>
-      <p:sp>
-        <p:nvSpPr>
-          <p:cNvPr id="34" name="Rounded Rectangle 33"/>
-          <p:cNvSpPr/>
-          <p:nvPr/>
-        </p:nvSpPr>
-        <p:spPr>
-          <a:xfrm>
-            <a:off x="6858000" y="2743200"/>
-            <a:ext cx="4572000" cy="868680"/>
-          </a:xfrm>
-          <a:prstGeom prst="roundRect">
-            <a:avLst/>
-          </a:prstGeom>
-          <a:solidFill>
-            <a:srgbClr val="FFFFFF"/>
-          </a:solidFill>
-          <a:ln w="12700">
-            <a:solidFill>
-              <a:srgbClr val="E2E8F0"/>
-            </a:solidFill>
-          </a:ln>
-        </p:spPr>
-        <p:style>
-          <a:lnRef idx="1">
-            <a:schemeClr val="accent1"/>
-          </a:lnRef>
-          <a:fillRef idx="3">
-            <a:schemeClr val="accent1"/>
-          </a:fillRef>
-          <a:effectRef idx="2">
-            <a:schemeClr val="accent1"/>
-          </a:effectRef>
-          <a:fontRef idx="minor">
-            <a:schemeClr val="lt1"/>
-          </a:fontRef>
-        </p:style>
-        <p:txBody>
-          <a:bodyPr rtlCol="0" anchor="ctr"/>
-          <a:lstStyle/>
-          <a:p>
-            <a:pPr algn="ctr"/>
-          </a:p>
-        </p:txBody>
-      </p:sp>
-      <p:sp>
-        <p:nvSpPr>
-          <p:cNvPr id="35" name="TextBox 34"/>
-          <p:cNvSpPr txBox="1"/>
-          <p:nvPr/>
-        </p:nvSpPr>
-        <p:spPr>
-          <a:xfrm>
-            <a:off x="7040880" y="2834640"/>
-            <a:ext cx="4206240" cy="182880"/>
-          </a:xfrm>
-          <a:prstGeom prst="rect">
-            <a:avLst/>
-          </a:prstGeom>
-          <a:noFill/>
-        </p:spPr>
-        <p:txBody>
-          <a:bodyPr wrap="square">
-            <a:spAutoFit/>
-          </a:bodyPr>
-          <a:lstStyle/>
-          <a:p>
-            <a:pPr algn="l">
-              <a:defRPr sz="900" b="1">
-                <a:solidFill>
-                  <a:srgbClr val="0F172A"/>
-                </a:solidFill>
-                <a:latin typeface="Calibri"/>
-              </a:defRPr>
-            </a:pPr>
-            <a:r>
-              <a:t>Pawan Kumar Singh</a:t>
-            </a:r>
-          </a:p>
-        </p:txBody>
-      </p:sp>
-      <p:sp>
-        <p:nvSpPr>
-          <p:cNvPr id="36" name="TextBox 35"/>
-          <p:cNvSpPr txBox="1"/>
-          <p:nvPr/>
-        </p:nvSpPr>
-        <p:spPr>
-          <a:xfrm>
-            <a:off x="7040880" y="3017520"/>
-            <a:ext cx="4206240" cy="137160"/>
-          </a:xfrm>
-          <a:prstGeom prst="rect">
-            <a:avLst/>
-          </a:prstGeom>
-          <a:noFill/>
-        </p:spPr>
-        <p:txBody>
-          <a:bodyPr wrap="square">
-            <a:spAutoFit/>
-          </a:bodyPr>
-          <a:lstStyle/>
-          <a:p>
-            <a:pPr algn="l">
-              <a:defRPr sz="700" b="1">
-                <a:solidFill>
-                  <a:srgbClr val="3B82F6"/>
-                </a:solidFill>
-                <a:latin typeface="Calibri"/>
-              </a:defRPr>
-            </a:pPr>
-            <a:r>
-              <a:t>AI / CV Engine</a:t>
-            </a:r>
-          </a:p>
-        </p:txBody>
-      </p:sp>
-      <p:sp>
-        <p:nvSpPr>
-          <p:cNvPr id="37" name="TextBox 36"/>
-          <p:cNvSpPr txBox="1"/>
-          <p:nvPr/>
-        </p:nvSpPr>
-        <p:spPr>
-          <a:xfrm>
-            <a:off x="7040880" y="3200400"/>
-            <a:ext cx="4206240" cy="320040"/>
-          </a:xfrm>
-          <a:prstGeom prst="rect">
-            <a:avLst/>
-          </a:prstGeom>
-          <a:noFill/>
-        </p:spPr>
-        <p:txBody>
-          <a:bodyPr wrap="square">
-            <a:spAutoFit/>
-          </a:bodyPr>
-          <a:lstStyle/>
-          <a:p>
-            <a:pPr algn="l">
-              <a:defRPr sz="700" b="0">
-                <a:solidFill>
-                  <a:srgbClr val="64748B"/>
-                </a:solidFill>
-                <a:latin typeface="Calibri"/>
-              </a:defRPr>
-            </a:pPr>
-            <a:r>
-              <a:t>YOLOv8 classifier, duplicate detection, priority model, training</a:t>
-            </a:r>
-          </a:p>
-        </p:txBody>
-      </p:sp>
-      <p:sp>
-        <p:nvSpPr>
-          <p:cNvPr id="38" name="Rounded Rectangle 37"/>
-          <p:cNvSpPr/>
-          <p:nvPr/>
-        </p:nvSpPr>
-        <p:spPr>
-          <a:xfrm>
-            <a:off x="6858000" y="3794760"/>
-            <a:ext cx="4572000" cy="868680"/>
-          </a:xfrm>
-          <a:prstGeom prst="roundRect">
-            <a:avLst/>
-          </a:prstGeom>
-          <a:solidFill>
-            <a:srgbClr val="FFFFFF"/>
-          </a:solidFill>
-          <a:ln w="12700">
-            <a:solidFill>
-              <a:srgbClr val="E2E8F0"/>
-            </a:solidFill>
-          </a:ln>
-        </p:spPr>
-        <p:style>
-          <a:lnRef idx="1">
-            <a:schemeClr val="accent1"/>
-          </a:lnRef>
-          <a:fillRef idx="3">
-            <a:schemeClr val="accent1"/>
-          </a:fillRef>
-          <a:effectRef idx="2">
-            <a:schemeClr val="accent1"/>
-          </a:effectRef>
-          <a:fontRef idx="minor">
-            <a:schemeClr val="lt1"/>
-          </a:fontRef>
-        </p:style>
-        <p:txBody>
-          <a:bodyPr rtlCol="0" anchor="ctr"/>
-          <a:lstStyle/>
-          <a:p>
-            <a:pPr algn="ctr"/>
-          </a:p>
-        </p:txBody>
-      </p:sp>
-      <p:sp>
-        <p:nvSpPr>
-          <p:cNvPr id="39" name="TextBox 38"/>
-          <p:cNvSpPr txBox="1"/>
-          <p:nvPr/>
-        </p:nvSpPr>
-        <p:spPr>
-          <a:xfrm>
-            <a:off x="7040880" y="3886200"/>
-            <a:ext cx="4206240" cy="182880"/>
-          </a:xfrm>
-          <a:prstGeom prst="rect">
-            <a:avLst/>
-          </a:prstGeom>
-          <a:noFill/>
-        </p:spPr>
-        <p:txBody>
-          <a:bodyPr wrap="square">
-            <a:spAutoFit/>
-          </a:bodyPr>
-          <a:lstStyle/>
-          <a:p>
-            <a:pPr algn="l">
-              <a:defRPr sz="900" b="1">
-                <a:solidFill>
-                  <a:srgbClr val="0F172A"/>
-                </a:solidFill>
-                <a:latin typeface="Calibri"/>
-              </a:defRPr>
-            </a:pPr>
-            <a:r>
-              <a:t>Ayush Mahajan</a:t>
-            </a:r>
-          </a:p>
-        </p:txBody>
-      </p:sp>
-      <p:sp>
-        <p:nvSpPr>
-          <p:cNvPr id="40" name="TextBox 39"/>
-          <p:cNvSpPr txBox="1"/>
-          <p:nvPr/>
-        </p:nvSpPr>
-        <p:spPr>
-          <a:xfrm>
-            <a:off x="7040880" y="4069080"/>
-            <a:ext cx="4206240" cy="137160"/>
-          </a:xfrm>
-          <a:prstGeom prst="rect">
-            <a:avLst/>
-          </a:prstGeom>
-          <a:noFill/>
-        </p:spPr>
-        <p:txBody>
-          <a:bodyPr wrap="square">
-            <a:spAutoFit/>
-          </a:bodyPr>
-          <a:lstStyle/>
-          <a:p>
-            <a:pPr algn="l">
-              <a:defRPr sz="700" b="1">
-                <a:solidFill>
-                  <a:srgbClr val="3B82F6"/>
-                </a:solidFill>
-                <a:latin typeface="Calibri"/>
-              </a:defRPr>
-            </a:pPr>
-            <a:r>
-              <a:t>Dashboards &amp; DevOps</a:t>
-            </a:r>
-          </a:p>
-        </p:txBody>
-      </p:sp>
-      <p:sp>
-        <p:nvSpPr>
-          <p:cNvPr id="41" name="TextBox 40"/>
-          <p:cNvSpPr txBox="1"/>
-          <p:nvPr/>
-        </p:nvSpPr>
-        <p:spPr>
-          <a:xfrm>
-            <a:off x="7040880" y="4251960"/>
-            <a:ext cx="4206240" cy="320040"/>
-          </a:xfrm>
-          <a:prstGeom prst="rect">
-            <a:avLst/>
-          </a:prstGeom>
-          <a:noFill/>
-        </p:spPr>
-        <p:txBody>
-          <a:bodyPr wrap="square">
-            <a:spAutoFit/>
-          </a:bodyPr>
-          <a:lstStyle/>
-          <a:p>
-            <a:pPr algn="l">
-              <a:defRPr sz="700" b="0">
-                <a:solidFill>
-                  <a:srgbClr val="64748B"/>
-                </a:solidFill>
-                <a:latin typeface="Calibri"/>
-              </a:defRPr>
-            </a:pPr>
-            <a:r>
-              <a:t>Officer + Admin dashboards, Recharts, Socket.IO, Docker deployment</a:t>
-            </a:r>
-          </a:p>
-        </p:txBody>
-      </p:sp>
-      <p:sp>
-        <p:nvSpPr>
-          <p:cNvPr id="42" name="Rounded Rectangle 41"/>
-          <p:cNvSpPr/>
-          <p:nvPr/>
-        </p:nvSpPr>
-        <p:spPr>
-          <a:xfrm>
-            <a:off x="6858000" y="4846320"/>
-            <a:ext cx="4572000" cy="868680"/>
-          </a:xfrm>
-          <a:prstGeom prst="roundRect">
-            <a:avLst/>
-          </a:prstGeom>
-          <a:solidFill>
-            <a:srgbClr val="FFFFFF"/>
-          </a:solidFill>
-          <a:ln w="12700">
-            <a:solidFill>
-              <a:srgbClr val="E2E8F0"/>
-            </a:solidFill>
-          </a:ln>
-        </p:spPr>
-        <p:style>
-          <a:lnRef idx="1">
-            <a:schemeClr val="accent1"/>
-          </a:lnRef>
-          <a:fillRef idx="3">
-            <a:schemeClr val="accent1"/>
-          </a:fillRef>
-          <a:effectRef idx="2">
-            <a:schemeClr val="accent1"/>
-          </a:effectRef>
-          <a:fontRef idx="minor">
-            <a:schemeClr val="lt1"/>
-          </a:fontRef>
-        </p:style>
-        <p:txBody>
-          <a:bodyPr rtlCol="0" anchor="ctr"/>
-          <a:lstStyle/>
-          <a:p>
-            <a:pPr algn="ctr"/>
-          </a:p>
-        </p:txBody>
-      </p:sp>
-      <p:sp>
-        <p:nvSpPr>
-          <p:cNvPr id="43" name="TextBox 42"/>
-          <p:cNvSpPr txBox="1"/>
-          <p:nvPr/>
-        </p:nvSpPr>
-        <p:spPr>
-          <a:xfrm>
-            <a:off x="7040880" y="4937760"/>
-            <a:ext cx="4206240" cy="182880"/>
-          </a:xfrm>
-          <a:prstGeom prst="rect">
-            <a:avLst/>
-          </a:prstGeom>
-          <a:noFill/>
-        </p:spPr>
-        <p:txBody>
-          <a:bodyPr wrap="square">
-            <a:spAutoFit/>
-          </a:bodyPr>
-          <a:lstStyle/>
-          <a:p>
-            <a:pPr algn="l">
-              <a:defRPr sz="900" b="1">
-                <a:solidFill>
-                  <a:srgbClr val="0F172A"/>
-                </a:solidFill>
-                <a:latin typeface="Calibri"/>
-              </a:defRPr>
-            </a:pPr>
-            <a:r>
-              <a:t>Chaitanya Purkar</a:t>
-            </a:r>
-          </a:p>
-        </p:txBody>
-      </p:sp>
-      <p:sp>
-        <p:nvSpPr>
-          <p:cNvPr id="44" name="TextBox 43"/>
-          <p:cNvSpPr txBox="1"/>
-          <p:nvPr/>
-        </p:nvSpPr>
-        <p:spPr>
-          <a:xfrm>
-            <a:off x="7040880" y="5120640"/>
-            <a:ext cx="4206240" cy="137160"/>
-          </a:xfrm>
-          <a:prstGeom prst="rect">
-            <a:avLst/>
-          </a:prstGeom>
-          <a:noFill/>
-        </p:spPr>
-        <p:txBody>
-          <a:bodyPr wrap="square">
-            <a:spAutoFit/>
-          </a:bodyPr>
-          <a:lstStyle/>
-          <a:p>
-            <a:pPr algn="l">
-              <a:defRPr sz="700" b="1">
-                <a:solidFill>
-                  <a:srgbClr val="3B82F6"/>
-                </a:solidFill>
-                <a:latin typeface="Calibri"/>
-              </a:defRPr>
-            </a:pPr>
-            <a:r>
-              <a:t>Backend &amp; Routing</a:t>
-            </a:r>
-          </a:p>
-        </p:txBody>
-      </p:sp>
-      <p:sp>
-        <p:nvSpPr>
-          <p:cNvPr id="45" name="TextBox 44"/>
-          <p:cNvSpPr txBox="1"/>
-          <p:nvPr/>
-        </p:nvSpPr>
-        <p:spPr>
-          <a:xfrm>
-            <a:off x="7040880" y="5303520"/>
-            <a:ext cx="4206240" cy="320040"/>
-          </a:xfrm>
-          <a:prstGeom prst="rect">
-            <a:avLst/>
-          </a:prstGeom>
-          <a:noFill/>
-        </p:spPr>
-        <p:txBody>
-          <a:bodyPr wrap="square">
-            <a:spAutoFit/>
-          </a:bodyPr>
-          <a:lstStyle/>
-          <a:p>
-            <a:pPr algn="l">
-              <a:defRPr sz="700" b="0">
-                <a:solidFill>
-                  <a:srgbClr val="64748B"/>
-                </a:solidFill>
-                <a:latin typeface="Calibri"/>
-              </a:defRPr>
-            </a:pPr>
-            <a:r>
-              <a:t>PostgreSQL schema, Express APIs, auto-routing, Redis cache &amp; security</a:t>
+              <a:t>Complete system: Citizen App, AI Engine, Dashboards, Backend, Deployment</a:t>
             </a:r>
           </a:p>
         </p:txBody>

</xml_diff>